<commit_message>
docs: remove private data from submission
</commit_message>
<xml_diff>
--- a/submission/AgentGuard-答辩PPT.pptx
+++ b/submission/AgentGuard-答辩PPT.pptx
@@ -2066,25 +2066,7 @@
                 </a:solidFill>
                 <a:latin typeface="Noto Sans CJK SC"/>
               </a:rPr>
-              <a:t>【待填写：正式队伍名称 </a:t>
-            </a:r>
-            <a:r>
-              <a:rPr b="0" lang="en-US" sz="1100" spc="-1" strike="noStrike">
-                <a:solidFill>
-                  <a:srgbClr val="9fb8c5"/>
-                </a:solidFill>
-                <a:latin typeface="Noto Sans CJK SC"/>
-              </a:rPr>
-              <a:t>/ </a:t>
-            </a:r>
-            <a:r>
-              <a:rPr b="0" lang="zh-CN" sz="1100" spc="-1" strike="noStrike">
-                <a:solidFill>
-                  <a:srgbClr val="9fb8c5"/>
-                </a:solidFill>
-                <a:latin typeface="Noto Sans CJK SC"/>
-              </a:rPr>
-              <a:t>成员真实姓名】</a:t>
+              <a:t>魔魔胡胡胡萝卜队｜队长：闫贺翔｜其他成员：无</a:t>
             </a:r>
             <a:endParaRPr b="0" lang="en-US" sz="1100" spc="-1" strike="noStrike">
               <a:latin typeface="Arial"/>
@@ -4668,7 +4650,7 @@
                 </a:solidFill>
                 <a:latin typeface="Noto Sans CJK SC"/>
               </a:rPr>
-              <a:t>16 / 2,229</a:t>
+              <a:t>15 / 1,820</a:t>
             </a:r>
             <a:endParaRPr b="0" lang="en-US" sz="2500" spc="-1" strike="noStrike">
               <a:latin typeface="Arial"/>
@@ -4723,7 +4705,7 @@
                 </a:solidFill>
                 <a:latin typeface="Noto Sans CJK SC"/>
               </a:rPr>
-              <a:t>2,421,811 Token</a:t>
+              <a:t>1,992,096 Token</a:t>
             </a:r>
             <a:r>
               <a:rPr b="0" lang="zh-CN" sz="1600" spc="-1" strike="noStrike">
@@ -5409,25 +5391,7 @@
                 </a:solidFill>
                 <a:latin typeface="Noto Sans CJK SC"/>
               </a:rPr>
-              <a:t>【待填写：正式队伍名称 </a:t>
-            </a:r>
-            <a:r>
-              <a:rPr b="0" lang="en-US" sz="1100" spc="-1" strike="noStrike">
-                <a:solidFill>
-                  <a:srgbClr val="9fb8c5"/>
-                </a:solidFill>
-                <a:latin typeface="Noto Sans CJK SC"/>
-              </a:rPr>
-              <a:t>/ </a:t>
-            </a:r>
-            <a:r>
-              <a:rPr b="0" lang="zh-CN" sz="1100" spc="-1" strike="noStrike">
-                <a:solidFill>
-                  <a:srgbClr val="9fb8c5"/>
-                </a:solidFill>
-                <a:latin typeface="Noto Sans CJK SC"/>
-              </a:rPr>
-              <a:t>成员真实姓名】</a:t>
+              <a:t>魔魔胡胡胡萝卜队｜队长：闫贺翔｜其他成员：无</a:t>
             </a:r>
             <a:endParaRPr b="0" lang="en-US" sz="1100" spc="-1" strike="noStrike">
               <a:latin typeface="Arial"/>

</xml_diff>

<commit_message>
docs: complete AI logs and submission materials
</commit_message>
<xml_diff>
--- a/submission/AgentGuard-答辩PPT.pptx
+++ b/submission/AgentGuard-答辩PPT.pptx
@@ -4650,7 +4650,7 @@
                 </a:solidFill>
                 <a:latin typeface="Noto Sans CJK SC"/>
               </a:rPr>
-              <a:t>15 / 1,820</a:t>
+              <a:t>37 / 10,970</a:t>
             </a:r>
             <a:endParaRPr b="0" lang="en-US" sz="2500" spc="-1" strike="noStrike">
               <a:latin typeface="Arial"/>
@@ -4705,7 +4705,7 @@
                 </a:solidFill>
                 <a:latin typeface="Noto Sans CJK SC"/>
               </a:rPr>
-              <a:t>1,992,096 Token</a:t>
+              <a:t>268,175,856 Token</a:t>
             </a:r>
             <a:r>
               <a:rPr b="0" lang="zh-CN" sz="1600" spc="-1" strike="noStrike">

</xml_diff>